<commit_message>
chore: Remove old VP readout (WW08-17), keep WW06-15 version
</commit_message>
<xml_diff>
--- a/sandbox/cdpm_recovery_app/MU_AppStore_Publishing_Journey.pptx
+++ b/sandbox/cdpm_recovery_app/MU_AppStore_Publishing_Journey.pptx
@@ -5,18 +5,19 @@
     <p:sldMasterId id="2147483648" r:id="rId1"/>
   </p:sldMasterIdLst>
   <p:sldIdLst>
-    <p:sldId id="256" r:id="rId7"/>
-    <p:sldId id="257" r:id="rId8"/>
-    <p:sldId id="258" r:id="rId9"/>
-    <p:sldId id="259" r:id="rId10"/>
-    <p:sldId id="260" r:id="rId11"/>
-    <p:sldId id="261" r:id="rId12"/>
-    <p:sldId id="262" r:id="rId13"/>
-    <p:sldId id="263" r:id="rId14"/>
-    <p:sldId id="264" r:id="rId15"/>
-    <p:sldId id="265" r:id="rId16"/>
-    <p:sldId id="266" r:id="rId17"/>
-    <p:sldId id="267" r:id="rId18"/>
+    <p:sldId id="256" r:id="rId2"/>
+    <p:sldId id="257" r:id="rId3"/>
+    <p:sldId id="258" r:id="rId4"/>
+    <p:sldId id="259" r:id="rId5"/>
+    <p:sldId id="260" r:id="rId6"/>
+    <p:sldId id="261" r:id="rId7"/>
+    <p:sldId id="262" r:id="rId8"/>
+    <p:sldId id="263" r:id="rId9"/>
+    <p:sldId id="264" r:id="rId10"/>
+    <p:sldId id="268" r:id="rId11"/>
+    <p:sldId id="265" r:id="rId12"/>
+    <p:sldId id="266" r:id="rId13"/>
+    <p:sldId id="267" r:id="rId14"/>
   </p:sldIdLst>
   <p:sldSz cx="9144000" cy="6858000" type="screen4x3"/>
   <p:notesSz cx="6858000" cy="9144000"/>
@@ -115,6 +116,22 @@
       </a:defRPr>
     </a:lvl9pPr>
   </p:defaultTextStyle>
+  <p:extLst>
+    <p:ext uri="{EFAFB233-063F-42B5-8137-9DF3F51BA10A}">
+      <p15:sldGuideLst xmlns:p15="http://schemas.microsoft.com/office/powerpoint/2012/main">
+        <p15:guide id="1" orient="horz" pos="2160">
+          <p15:clr>
+            <a:srgbClr val="A4A3A4"/>
+          </p15:clr>
+        </p15:guide>
+        <p15:guide id="2" pos="2880">
+          <p15:clr>
+            <a:srgbClr val="A4A3A4"/>
+          </p15:clr>
+        </p15:guide>
+      </p15:sldGuideLst>
+    </p:ext>
+  </p:extLst>
 </p:presentation>
 </file>
 
@@ -156,10 +173,9 @@
           <a:lstStyle/>
           <a:p>
             <a:r>
-              <a:rPr lang="en-US" smtClean="0"/>
+              <a:rPr lang="en-US"/>
               <a:t>Click to edit Master title style</a:t>
             </a:r>
-            <a:endParaRPr lang="en-US"/>
           </a:p>
         </p:txBody>
       </p:sp>
@@ -275,10 +291,9 @@
           </a:lstStyle>
           <a:p>
             <a:r>
-              <a:rPr lang="en-US" smtClean="0"/>
+              <a:rPr lang="en-US"/>
               <a:t>Click to edit Master subtitle style</a:t>
             </a:r>
-            <a:endParaRPr lang="en-US"/>
           </a:p>
         </p:txBody>
       </p:sp>
@@ -299,7 +314,7 @@
           <a:p>
             <a:fld id="{5BCAD085-E8A6-8845-BD4E-CB4CCA059FC4}" type="datetimeFigureOut">
               <a:rPr lang="en-US" smtClean="0"/>
-              <a:t>1/27/13</a:t>
+              <a:t>4/22/2026</a:t>
             </a:fld>
             <a:endParaRPr lang="en-US"/>
           </a:p>
@@ -393,10 +408,9 @@
           <a:lstStyle/>
           <a:p>
             <a:r>
-              <a:rPr lang="en-US" smtClean="0"/>
+              <a:rPr lang="en-US"/>
               <a:t>Click to edit Master title style</a:t>
             </a:r>
-            <a:endParaRPr lang="en-US"/>
           </a:p>
         </p:txBody>
       </p:sp>
@@ -417,38 +431,37 @@
           <a:p>
             <a:pPr lvl="0"/>
             <a:r>
-              <a:rPr lang="en-US" smtClean="0"/>
+              <a:rPr lang="en-US"/>
               <a:t>Click to edit Master text styles</a:t>
             </a:r>
           </a:p>
           <a:p>
             <a:pPr lvl="1"/>
             <a:r>
-              <a:rPr lang="en-US" smtClean="0"/>
+              <a:rPr lang="en-US"/>
               <a:t>Second level</a:t>
             </a:r>
           </a:p>
           <a:p>
             <a:pPr lvl="2"/>
             <a:r>
-              <a:rPr lang="en-US" smtClean="0"/>
+              <a:rPr lang="en-US"/>
               <a:t>Third level</a:t>
             </a:r>
           </a:p>
           <a:p>
             <a:pPr lvl="3"/>
             <a:r>
-              <a:rPr lang="en-US" smtClean="0"/>
+              <a:rPr lang="en-US"/>
               <a:t>Fourth level</a:t>
             </a:r>
           </a:p>
           <a:p>
             <a:pPr lvl="4"/>
             <a:r>
-              <a:rPr lang="en-US" smtClean="0"/>
+              <a:rPr lang="en-US"/>
               <a:t>Fifth level</a:t>
             </a:r>
-            <a:endParaRPr lang="en-US"/>
           </a:p>
         </p:txBody>
       </p:sp>
@@ -469,7 +482,7 @@
           <a:p>
             <a:fld id="{5BCAD085-E8A6-8845-BD4E-CB4CCA059FC4}" type="datetimeFigureOut">
               <a:rPr lang="en-US" smtClean="0"/>
-              <a:t>1/27/13</a:t>
+              <a:t>4/22/2026</a:t>
             </a:fld>
             <a:endParaRPr lang="en-US"/>
           </a:p>
@@ -568,10 +581,9 @@
           <a:lstStyle/>
           <a:p>
             <a:r>
-              <a:rPr lang="en-US" smtClean="0"/>
+              <a:rPr lang="en-US"/>
               <a:t>Click to edit Master title style</a:t>
             </a:r>
-            <a:endParaRPr lang="en-US"/>
           </a:p>
         </p:txBody>
       </p:sp>
@@ -597,38 +609,37 @@
           <a:p>
             <a:pPr lvl="0"/>
             <a:r>
-              <a:rPr lang="en-US" smtClean="0"/>
+              <a:rPr lang="en-US"/>
               <a:t>Click to edit Master text styles</a:t>
             </a:r>
           </a:p>
           <a:p>
             <a:pPr lvl="1"/>
             <a:r>
-              <a:rPr lang="en-US" smtClean="0"/>
+              <a:rPr lang="en-US"/>
               <a:t>Second level</a:t>
             </a:r>
           </a:p>
           <a:p>
             <a:pPr lvl="2"/>
             <a:r>
-              <a:rPr lang="en-US" smtClean="0"/>
+              <a:rPr lang="en-US"/>
               <a:t>Third level</a:t>
             </a:r>
           </a:p>
           <a:p>
             <a:pPr lvl="3"/>
             <a:r>
-              <a:rPr lang="en-US" smtClean="0"/>
+              <a:rPr lang="en-US"/>
               <a:t>Fourth level</a:t>
             </a:r>
           </a:p>
           <a:p>
             <a:pPr lvl="4"/>
             <a:r>
-              <a:rPr lang="en-US" smtClean="0"/>
+              <a:rPr lang="en-US"/>
               <a:t>Fifth level</a:t>
             </a:r>
-            <a:endParaRPr lang="en-US"/>
           </a:p>
         </p:txBody>
       </p:sp>
@@ -649,7 +660,7 @@
           <a:p>
             <a:fld id="{5BCAD085-E8A6-8845-BD4E-CB4CCA059FC4}" type="datetimeFigureOut">
               <a:rPr lang="en-US" smtClean="0"/>
-              <a:t>1/27/13</a:t>
+              <a:t>4/22/2026</a:t>
             </a:fld>
             <a:endParaRPr lang="en-US"/>
           </a:p>
@@ -743,10 +754,9 @@
           <a:lstStyle/>
           <a:p>
             <a:r>
-              <a:rPr lang="en-US" smtClean="0"/>
+              <a:rPr lang="en-US"/>
               <a:t>Click to edit Master title style</a:t>
             </a:r>
-            <a:endParaRPr lang="en-US"/>
           </a:p>
         </p:txBody>
       </p:sp>
@@ -767,38 +777,37 @@
           <a:p>
             <a:pPr lvl="0"/>
             <a:r>
-              <a:rPr lang="en-US" smtClean="0"/>
+              <a:rPr lang="en-US"/>
               <a:t>Click to edit Master text styles</a:t>
             </a:r>
           </a:p>
           <a:p>
             <a:pPr lvl="1"/>
             <a:r>
-              <a:rPr lang="en-US" smtClean="0"/>
+              <a:rPr lang="en-US"/>
               <a:t>Second level</a:t>
             </a:r>
           </a:p>
           <a:p>
             <a:pPr lvl="2"/>
             <a:r>
-              <a:rPr lang="en-US" smtClean="0"/>
+              <a:rPr lang="en-US"/>
               <a:t>Third level</a:t>
             </a:r>
           </a:p>
           <a:p>
             <a:pPr lvl="3"/>
             <a:r>
-              <a:rPr lang="en-US" smtClean="0"/>
+              <a:rPr lang="en-US"/>
               <a:t>Fourth level</a:t>
             </a:r>
           </a:p>
           <a:p>
             <a:pPr lvl="4"/>
             <a:r>
-              <a:rPr lang="en-US" smtClean="0"/>
+              <a:rPr lang="en-US"/>
               <a:t>Fifth level</a:t>
             </a:r>
-            <a:endParaRPr lang="en-US"/>
           </a:p>
         </p:txBody>
       </p:sp>
@@ -819,7 +828,7 @@
           <a:p>
             <a:fld id="{5BCAD085-E8A6-8845-BD4E-CB4CCA059FC4}" type="datetimeFigureOut">
               <a:rPr lang="en-US" smtClean="0"/>
-              <a:t>1/27/13</a:t>
+              <a:t>4/22/2026</a:t>
             </a:fld>
             <a:endParaRPr lang="en-US"/>
           </a:p>
@@ -922,10 +931,9 @@
           </a:lstStyle>
           <a:p>
             <a:r>
-              <a:rPr lang="en-US" smtClean="0"/>
+              <a:rPr lang="en-US"/>
               <a:t>Click to edit Master title style</a:t>
             </a:r>
-            <a:endParaRPr lang="en-US"/>
           </a:p>
         </p:txBody>
       </p:sp>
@@ -1042,7 +1050,7 @@
           <a:p>
             <a:pPr lvl="0"/>
             <a:r>
-              <a:rPr lang="en-US" smtClean="0"/>
+              <a:rPr lang="en-US"/>
               <a:t>Click to edit Master text styles</a:t>
             </a:r>
           </a:p>
@@ -1065,7 +1073,7 @@
           <a:p>
             <a:fld id="{5BCAD085-E8A6-8845-BD4E-CB4CCA059FC4}" type="datetimeFigureOut">
               <a:rPr lang="en-US" smtClean="0"/>
-              <a:t>1/27/13</a:t>
+              <a:t>4/22/2026</a:t>
             </a:fld>
             <a:endParaRPr lang="en-US"/>
           </a:p>
@@ -1159,10 +1167,9 @@
           <a:lstStyle/>
           <a:p>
             <a:r>
-              <a:rPr lang="en-US" smtClean="0"/>
+              <a:rPr lang="en-US"/>
               <a:t>Click to edit Master title style</a:t>
             </a:r>
-            <a:endParaRPr lang="en-US"/>
           </a:p>
         </p:txBody>
       </p:sp>
@@ -1216,38 +1223,37 @@
           <a:p>
             <a:pPr lvl="0"/>
             <a:r>
-              <a:rPr lang="en-US" smtClean="0"/>
+              <a:rPr lang="en-US"/>
               <a:t>Click to edit Master text styles</a:t>
             </a:r>
           </a:p>
           <a:p>
             <a:pPr lvl="1"/>
             <a:r>
-              <a:rPr lang="en-US" smtClean="0"/>
+              <a:rPr lang="en-US"/>
               <a:t>Second level</a:t>
             </a:r>
           </a:p>
           <a:p>
             <a:pPr lvl="2"/>
             <a:r>
-              <a:rPr lang="en-US" smtClean="0"/>
+              <a:rPr lang="en-US"/>
               <a:t>Third level</a:t>
             </a:r>
           </a:p>
           <a:p>
             <a:pPr lvl="3"/>
             <a:r>
-              <a:rPr lang="en-US" smtClean="0"/>
+              <a:rPr lang="en-US"/>
               <a:t>Fourth level</a:t>
             </a:r>
           </a:p>
           <a:p>
             <a:pPr lvl="4"/>
             <a:r>
-              <a:rPr lang="en-US" smtClean="0"/>
+              <a:rPr lang="en-US"/>
               <a:t>Fifth level</a:t>
             </a:r>
-            <a:endParaRPr lang="en-US"/>
           </a:p>
         </p:txBody>
       </p:sp>
@@ -1301,38 +1307,37 @@
           <a:p>
             <a:pPr lvl="0"/>
             <a:r>
-              <a:rPr lang="en-US" smtClean="0"/>
+              <a:rPr lang="en-US"/>
               <a:t>Click to edit Master text styles</a:t>
             </a:r>
           </a:p>
           <a:p>
             <a:pPr lvl="1"/>
             <a:r>
-              <a:rPr lang="en-US" smtClean="0"/>
+              <a:rPr lang="en-US"/>
               <a:t>Second level</a:t>
             </a:r>
           </a:p>
           <a:p>
             <a:pPr lvl="2"/>
             <a:r>
-              <a:rPr lang="en-US" smtClean="0"/>
+              <a:rPr lang="en-US"/>
               <a:t>Third level</a:t>
             </a:r>
           </a:p>
           <a:p>
             <a:pPr lvl="3"/>
             <a:r>
-              <a:rPr lang="en-US" smtClean="0"/>
+              <a:rPr lang="en-US"/>
               <a:t>Fourth level</a:t>
             </a:r>
           </a:p>
           <a:p>
             <a:pPr lvl="4"/>
             <a:r>
-              <a:rPr lang="en-US" smtClean="0"/>
+              <a:rPr lang="en-US"/>
               <a:t>Fifth level</a:t>
             </a:r>
-            <a:endParaRPr lang="en-US"/>
           </a:p>
         </p:txBody>
       </p:sp>
@@ -1353,7 +1358,7 @@
           <a:p>
             <a:fld id="{5BCAD085-E8A6-8845-BD4E-CB4CCA059FC4}" type="datetimeFigureOut">
               <a:rPr lang="en-US" smtClean="0"/>
-              <a:t>1/27/13</a:t>
+              <a:t>4/22/2026</a:t>
             </a:fld>
             <a:endParaRPr lang="en-US"/>
           </a:p>
@@ -1451,10 +1456,9 @@
           </a:lstStyle>
           <a:p>
             <a:r>
-              <a:rPr lang="en-US" smtClean="0"/>
+              <a:rPr lang="en-US"/>
               <a:t>Click to edit Master title style</a:t>
             </a:r>
-            <a:endParaRPr lang="en-US"/>
           </a:p>
         </p:txBody>
       </p:sp>
@@ -1517,7 +1521,7 @@
           <a:p>
             <a:pPr lvl="0"/>
             <a:r>
-              <a:rPr lang="en-US" smtClean="0"/>
+              <a:rPr lang="en-US"/>
               <a:t>Click to edit Master text styles</a:t>
             </a:r>
           </a:p>
@@ -1573,38 +1577,37 @@
           <a:p>
             <a:pPr lvl="0"/>
             <a:r>
-              <a:rPr lang="en-US" smtClean="0"/>
+              <a:rPr lang="en-US"/>
               <a:t>Click to edit Master text styles</a:t>
             </a:r>
           </a:p>
           <a:p>
             <a:pPr lvl="1"/>
             <a:r>
-              <a:rPr lang="en-US" smtClean="0"/>
+              <a:rPr lang="en-US"/>
               <a:t>Second level</a:t>
             </a:r>
           </a:p>
           <a:p>
             <a:pPr lvl="2"/>
             <a:r>
-              <a:rPr lang="en-US" smtClean="0"/>
+              <a:rPr lang="en-US"/>
               <a:t>Third level</a:t>
             </a:r>
           </a:p>
           <a:p>
             <a:pPr lvl="3"/>
             <a:r>
-              <a:rPr lang="en-US" smtClean="0"/>
+              <a:rPr lang="en-US"/>
               <a:t>Fourth level</a:t>
             </a:r>
           </a:p>
           <a:p>
             <a:pPr lvl="4"/>
             <a:r>
-              <a:rPr lang="en-US" smtClean="0"/>
+              <a:rPr lang="en-US"/>
               <a:t>Fifth level</a:t>
             </a:r>
-            <a:endParaRPr lang="en-US"/>
           </a:p>
         </p:txBody>
       </p:sp>
@@ -1667,7 +1670,7 @@
           <a:p>
             <a:pPr lvl="0"/>
             <a:r>
-              <a:rPr lang="en-US" smtClean="0"/>
+              <a:rPr lang="en-US"/>
               <a:t>Click to edit Master text styles</a:t>
             </a:r>
           </a:p>
@@ -1723,38 +1726,37 @@
           <a:p>
             <a:pPr lvl="0"/>
             <a:r>
-              <a:rPr lang="en-US" smtClean="0"/>
+              <a:rPr lang="en-US"/>
               <a:t>Click to edit Master text styles</a:t>
             </a:r>
           </a:p>
           <a:p>
             <a:pPr lvl="1"/>
             <a:r>
-              <a:rPr lang="en-US" smtClean="0"/>
+              <a:rPr lang="en-US"/>
               <a:t>Second level</a:t>
             </a:r>
           </a:p>
           <a:p>
             <a:pPr lvl="2"/>
             <a:r>
-              <a:rPr lang="en-US" smtClean="0"/>
+              <a:rPr lang="en-US"/>
               <a:t>Third level</a:t>
             </a:r>
           </a:p>
           <a:p>
             <a:pPr lvl="3"/>
             <a:r>
-              <a:rPr lang="en-US" smtClean="0"/>
+              <a:rPr lang="en-US"/>
               <a:t>Fourth level</a:t>
             </a:r>
           </a:p>
           <a:p>
             <a:pPr lvl="4"/>
             <a:r>
-              <a:rPr lang="en-US" smtClean="0"/>
+              <a:rPr lang="en-US"/>
               <a:t>Fifth level</a:t>
             </a:r>
-            <a:endParaRPr lang="en-US"/>
           </a:p>
         </p:txBody>
       </p:sp>
@@ -1775,7 +1777,7 @@
           <a:p>
             <a:fld id="{5BCAD085-E8A6-8845-BD4E-CB4CCA059FC4}" type="datetimeFigureOut">
               <a:rPr lang="en-US" smtClean="0"/>
-              <a:t>1/27/13</a:t>
+              <a:t>4/22/2026</a:t>
             </a:fld>
             <a:endParaRPr lang="en-US"/>
           </a:p>
@@ -1869,10 +1871,9 @@
           <a:lstStyle/>
           <a:p>
             <a:r>
-              <a:rPr lang="en-US" smtClean="0"/>
+              <a:rPr lang="en-US"/>
               <a:t>Click to edit Master title style</a:t>
             </a:r>
-            <a:endParaRPr lang="en-US"/>
           </a:p>
         </p:txBody>
       </p:sp>
@@ -1893,7 +1894,7 @@
           <a:p>
             <a:fld id="{5BCAD085-E8A6-8845-BD4E-CB4CCA059FC4}" type="datetimeFigureOut">
               <a:rPr lang="en-US" smtClean="0"/>
-              <a:t>1/27/13</a:t>
+              <a:t>4/22/2026</a:t>
             </a:fld>
             <a:endParaRPr lang="en-US"/>
           </a:p>
@@ -1988,7 +1989,7 @@
           <a:p>
             <a:fld id="{5BCAD085-E8A6-8845-BD4E-CB4CCA059FC4}" type="datetimeFigureOut">
               <a:rPr lang="en-US" smtClean="0"/>
-              <a:t>1/27/13</a:t>
+              <a:t>4/22/2026</a:t>
             </a:fld>
             <a:endParaRPr lang="en-US"/>
           </a:p>
@@ -2091,10 +2092,9 @@
           </a:lstStyle>
           <a:p>
             <a:r>
-              <a:rPr lang="en-US" smtClean="0"/>
+              <a:rPr lang="en-US"/>
               <a:t>Click to edit Master title style</a:t>
             </a:r>
-            <a:endParaRPr lang="en-US"/>
           </a:p>
         </p:txBody>
       </p:sp>
@@ -2148,38 +2148,37 @@
           <a:p>
             <a:pPr lvl="0"/>
             <a:r>
-              <a:rPr lang="en-US" smtClean="0"/>
+              <a:rPr lang="en-US"/>
               <a:t>Click to edit Master text styles</a:t>
             </a:r>
           </a:p>
           <a:p>
             <a:pPr lvl="1"/>
             <a:r>
-              <a:rPr lang="en-US" smtClean="0"/>
+              <a:rPr lang="en-US"/>
               <a:t>Second level</a:t>
             </a:r>
           </a:p>
           <a:p>
             <a:pPr lvl="2"/>
             <a:r>
-              <a:rPr lang="en-US" smtClean="0"/>
+              <a:rPr lang="en-US"/>
               <a:t>Third level</a:t>
             </a:r>
           </a:p>
           <a:p>
             <a:pPr lvl="3"/>
             <a:r>
-              <a:rPr lang="en-US" smtClean="0"/>
+              <a:rPr lang="en-US"/>
               <a:t>Fourth level</a:t>
             </a:r>
           </a:p>
           <a:p>
             <a:pPr lvl="4"/>
             <a:r>
-              <a:rPr lang="en-US" smtClean="0"/>
+              <a:rPr lang="en-US"/>
               <a:t>Fifth level</a:t>
             </a:r>
-            <a:endParaRPr lang="en-US"/>
           </a:p>
         </p:txBody>
       </p:sp>
@@ -2242,7 +2241,7 @@
           <a:p>
             <a:pPr lvl="0"/>
             <a:r>
-              <a:rPr lang="en-US" smtClean="0"/>
+              <a:rPr lang="en-US"/>
               <a:t>Click to edit Master text styles</a:t>
             </a:r>
           </a:p>
@@ -2265,7 +2264,7 @@
           <a:p>
             <a:fld id="{5BCAD085-E8A6-8845-BD4E-CB4CCA059FC4}" type="datetimeFigureOut">
               <a:rPr lang="en-US" smtClean="0"/>
-              <a:t>1/27/13</a:t>
+              <a:t>4/22/2026</a:t>
             </a:fld>
             <a:endParaRPr lang="en-US"/>
           </a:p>
@@ -2368,10 +2367,9 @@
           </a:lstStyle>
           <a:p>
             <a:r>
-              <a:rPr lang="en-US" smtClean="0"/>
+              <a:rPr lang="en-US"/>
               <a:t>Click to edit Master title style</a:t>
             </a:r>
-            <a:endParaRPr lang="en-US"/>
           </a:p>
         </p:txBody>
       </p:sp>
@@ -2495,7 +2493,7 @@
           <a:p>
             <a:pPr lvl="0"/>
             <a:r>
-              <a:rPr lang="en-US" smtClean="0"/>
+              <a:rPr lang="en-US"/>
               <a:t>Click to edit Master text styles</a:t>
             </a:r>
           </a:p>
@@ -2518,7 +2516,7 @@
           <a:p>
             <a:fld id="{5BCAD085-E8A6-8845-BD4E-CB4CCA059FC4}" type="datetimeFigureOut">
               <a:rPr lang="en-US" smtClean="0"/>
-              <a:t>1/27/13</a:t>
+              <a:t>4/22/2026</a:t>
             </a:fld>
             <a:endParaRPr lang="en-US"/>
           </a:p>
@@ -2627,10 +2625,9 @@
           <a:lstStyle/>
           <a:p>
             <a:r>
-              <a:rPr lang="en-US" smtClean="0"/>
+              <a:rPr lang="en-US"/>
               <a:t>Click to edit Master title style</a:t>
             </a:r>
-            <a:endParaRPr lang="en-US"/>
           </a:p>
         </p:txBody>
       </p:sp>
@@ -2661,38 +2658,37 @@
           <a:p>
             <a:pPr lvl="0"/>
             <a:r>
-              <a:rPr lang="en-US" smtClean="0"/>
+              <a:rPr lang="en-US"/>
               <a:t>Click to edit Master text styles</a:t>
             </a:r>
           </a:p>
           <a:p>
             <a:pPr lvl="1"/>
             <a:r>
-              <a:rPr lang="en-US" smtClean="0"/>
+              <a:rPr lang="en-US"/>
               <a:t>Second level</a:t>
             </a:r>
           </a:p>
           <a:p>
             <a:pPr lvl="2"/>
             <a:r>
-              <a:rPr lang="en-US" smtClean="0"/>
+              <a:rPr lang="en-US"/>
               <a:t>Third level</a:t>
             </a:r>
           </a:p>
           <a:p>
             <a:pPr lvl="3"/>
             <a:r>
-              <a:rPr lang="en-US" smtClean="0"/>
+              <a:rPr lang="en-US"/>
               <a:t>Fourth level</a:t>
             </a:r>
           </a:p>
           <a:p>
             <a:pPr lvl="4"/>
             <a:r>
-              <a:rPr lang="en-US" smtClean="0"/>
+              <a:rPr lang="en-US"/>
               <a:t>Fifth level</a:t>
             </a:r>
-            <a:endParaRPr lang="en-US"/>
           </a:p>
         </p:txBody>
       </p:sp>
@@ -2731,7 +2727,7 @@
           <a:p>
             <a:fld id="{5BCAD085-E8A6-8845-BD4E-CB4CCA059FC4}" type="datetimeFigureOut">
               <a:rPr lang="en-US" smtClean="0"/>
-              <a:t>1/27/13</a:t>
+              <a:t>4/22/2026</a:t>
             </a:fld>
             <a:endParaRPr lang="en-US"/>
           </a:p>
@@ -2812,6 +2808,104 @@
               <a:t>‹#›</a:t>
             </a:fld>
             <a:endParaRPr lang="en-US"/>
+          </a:p>
+        </p:txBody>
+      </p:sp>
+      <p:sp>
+        <p:nvSpPr>
+          <p:cNvPr id="9" name="TextBox 8">
+            <a:extLst>
+              <a:ext uri="{FF2B5EF4-FFF2-40B4-BE49-F238E27FC236}">
+                <a16:creationId xmlns:a16="http://schemas.microsoft.com/office/drawing/2014/main" id="{0223CA9D-08EF-1D54-57C6-9F106BA2E310}"/>
+              </a:ext>
+            </a:extLst>
+          </p:cNvPr>
+          <p:cNvSpPr txBox="1"/>
+          <p:nvPr userDrawn="1">
+            <p:extLst>
+              <p:ext uri="{1162E1C5-73C7-4A58-AE30-91384D911F3F}">
+                <p184:classification xmlns:p184="http://schemas.microsoft.com/office/powerpoint/2018/4/main" val="hdr"/>
+              </p:ext>
+            </p:extLst>
+          </p:nvPr>
+        </p:nvSpPr>
+        <p:spPr>
+          <a:xfrm>
+            <a:off x="63500" y="63500"/>
+            <a:ext cx="1341438" cy="182880"/>
+          </a:xfrm>
+          <a:prstGeom prst="rect">
+            <a:avLst/>
+          </a:prstGeom>
+        </p:spPr>
+        <p:txBody>
+          <a:bodyPr horzOverflow="overflow" lIns="0" tIns="0" rIns="0" bIns="0">
+            <a:spAutoFit/>
+          </a:bodyPr>
+          <a:lstStyle/>
+          <a:p>
+            <a:pPr algn="l"/>
+            <a:r>
+              <a:rPr lang="en-US" sz="1200">
+                <a:solidFill>
+                  <a:srgbClr val="000000">
+                    <a:alpha val="50000"/>
+                  </a:srgbClr>
+                </a:solidFill>
+                <a:latin typeface="Arial" panose="020B0604020202020204" pitchFamily="34" charset="0"/>
+                <a:cs typeface="Arial" panose="020B0604020202020204" pitchFamily="34" charset="0"/>
+              </a:rPr>
+              <a:t>Micron Confidential</a:t>
+            </a:r>
+          </a:p>
+        </p:txBody>
+      </p:sp>
+      <p:sp>
+        <p:nvSpPr>
+          <p:cNvPr id="10" name="TextBox 9">
+            <a:extLst>
+              <a:ext uri="{FF2B5EF4-FFF2-40B4-BE49-F238E27FC236}">
+                <a16:creationId xmlns:a16="http://schemas.microsoft.com/office/drawing/2014/main" id="{605F8538-E4D5-C3B7-C7E1-5E1B52AE147E}"/>
+              </a:ext>
+            </a:extLst>
+          </p:cNvPr>
+          <p:cNvSpPr txBox="1"/>
+          <p:nvPr userDrawn="1">
+            <p:extLst>
+              <p:ext uri="{1162E1C5-73C7-4A58-AE30-91384D911F3F}">
+                <p184:classification xmlns:p184="http://schemas.microsoft.com/office/powerpoint/2018/4/main" val="ftr"/>
+              </p:ext>
+            </p:extLst>
+          </p:nvPr>
+        </p:nvSpPr>
+        <p:spPr>
+          <a:xfrm>
+            <a:off x="63500" y="6611620"/>
+            <a:ext cx="1341438" cy="182880"/>
+          </a:xfrm>
+          <a:prstGeom prst="rect">
+            <a:avLst/>
+          </a:prstGeom>
+        </p:spPr>
+        <p:txBody>
+          <a:bodyPr horzOverflow="overflow" lIns="0" tIns="0" rIns="0" bIns="0">
+            <a:spAutoFit/>
+          </a:bodyPr>
+          <a:lstStyle/>
+          <a:p>
+            <a:pPr algn="l"/>
+            <a:r>
+              <a:rPr lang="en-US" sz="1200">
+                <a:solidFill>
+                  <a:srgbClr val="000000">
+                    <a:alpha val="50000"/>
+                  </a:srgbClr>
+                </a:solidFill>
+                <a:latin typeface="Arial" panose="020B0604020202020204" pitchFamily="34" charset="0"/>
+                <a:cs typeface="Arial" panose="020B0604020202020204" pitchFamily="34" charset="0"/>
+              </a:rPr>
+              <a:t>Micron Confidential</a:t>
+            </a:r>
           </a:p>
         </p:txBody>
       </p:sp>
@@ -3090,7 +3184,7 @@
 </file>
 
 <file path=ppt/slides/slide1.xml><?xml version="1.0" encoding="utf-8"?>
-<p:sld xmlns:a="http://schemas.openxmlformats.org/drawingml/2006/main" xmlns:p="http://schemas.openxmlformats.org/presentationml/2006/main" xmlns:r="http://schemas.openxmlformats.org/officeDocument/2006/relationships">
+<p:sld xmlns:a="http://schemas.openxmlformats.org/drawingml/2006/main" xmlns:r="http://schemas.openxmlformats.org/officeDocument/2006/relationships" xmlns:p="http://schemas.openxmlformats.org/presentationml/2006/main">
   <p:cSld>
     <p:spTree>
       <p:nvGrpSpPr>
@@ -3098,7 +3192,14 @@
         <p:cNvGrpSpPr/>
         <p:nvPr/>
       </p:nvGrpSpPr>
-      <p:grpSpPr/>
+      <p:grpSpPr>
+        <a:xfrm>
+          <a:off x="0" y="0"/>
+          <a:ext cx="0" cy="0"/>
+          <a:chOff x="0" y="0"/>
+          <a:chExt cx="0" cy="0"/>
+        </a:xfrm>
+      </p:grpSpPr>
       <p:sp>
         <p:nvSpPr>
           <p:cNvPr id="2" name="Rectangle 1"/>
@@ -3139,6 +3240,7 @@
           <a:lstStyle/>
           <a:p>
             <a:pPr algn="ctr"/>
+            <a:endParaRPr/>
           </a:p>
         </p:txBody>
       </p:sp>
@@ -3225,7 +3327,7 @@
 </file>
 
 <file path=ppt/slides/slide10.xml><?xml version="1.0" encoding="utf-8"?>
-<p:sld xmlns:a="http://schemas.openxmlformats.org/drawingml/2006/main" xmlns:p="http://schemas.openxmlformats.org/presentationml/2006/main" xmlns:r="http://schemas.openxmlformats.org/officeDocument/2006/relationships">
+<p:sld xmlns:a="http://schemas.openxmlformats.org/drawingml/2006/main" xmlns:r="http://schemas.openxmlformats.org/officeDocument/2006/relationships" xmlns:p="http://schemas.openxmlformats.org/presentationml/2006/main">
   <p:cSld>
     <p:spTree>
       <p:nvGrpSpPr>
@@ -3233,7 +3335,104 @@
         <p:cNvGrpSpPr/>
         <p:nvPr/>
       </p:nvGrpSpPr>
-      <p:grpSpPr/>
+      <p:grpSpPr>
+        <a:xfrm>
+          <a:off x="0" y="0"/>
+          <a:ext cx="0" cy="0"/>
+          <a:chOff x="0" y="0"/>
+          <a:chExt cx="0" cy="0"/>
+        </a:xfrm>
+      </p:grpSpPr>
+      <p:pic>
+        <p:nvPicPr>
+          <p:cNvPr id="3" name="Picture 2">
+            <a:extLst>
+              <a:ext uri="{FF2B5EF4-FFF2-40B4-BE49-F238E27FC236}">
+                <a16:creationId xmlns:a16="http://schemas.microsoft.com/office/drawing/2014/main" id="{F128D646-84C2-640D-6F0E-8360491B20C9}"/>
+              </a:ext>
+            </a:extLst>
+          </p:cNvPr>
+          <p:cNvPicPr>
+            <a:picLocks noChangeAspect="1"/>
+          </p:cNvPicPr>
+          <p:nvPr/>
+        </p:nvPicPr>
+        <p:blipFill>
+          <a:blip r:embed="rId2"/>
+          <a:stretch>
+            <a:fillRect/>
+          </a:stretch>
+        </p:blipFill>
+        <p:spPr>
+          <a:xfrm>
+            <a:off x="206150" y="4116137"/>
+            <a:ext cx="8731699" cy="2082907"/>
+          </a:xfrm>
+          <a:prstGeom prst="rect">
+            <a:avLst/>
+          </a:prstGeom>
+        </p:spPr>
+      </p:pic>
+      <p:pic>
+        <p:nvPicPr>
+          <p:cNvPr id="7" name="Picture 6">
+            <a:extLst>
+              <a:ext uri="{FF2B5EF4-FFF2-40B4-BE49-F238E27FC236}">
+                <a16:creationId xmlns:a16="http://schemas.microsoft.com/office/drawing/2014/main" id="{B1F0C224-8043-EE04-0DE6-2FA50C52F993}"/>
+              </a:ext>
+            </a:extLst>
+          </p:cNvPr>
+          <p:cNvPicPr>
+            <a:picLocks noChangeAspect="1"/>
+          </p:cNvPicPr>
+          <p:nvPr/>
+        </p:nvPicPr>
+        <p:blipFill>
+          <a:blip r:embed="rId3"/>
+          <a:stretch>
+            <a:fillRect/>
+          </a:stretch>
+        </p:blipFill>
+        <p:spPr>
+          <a:xfrm>
+            <a:off x="410226" y="1030853"/>
+            <a:ext cx="8323545" cy="2242456"/>
+          </a:xfrm>
+          <a:prstGeom prst="rect">
+            <a:avLst/>
+          </a:prstGeom>
+        </p:spPr>
+      </p:pic>
+    </p:spTree>
+    <p:extLst>
+      <p:ext uri="{BB962C8B-B14F-4D97-AF65-F5344CB8AC3E}">
+        <p14:creationId xmlns:p14="http://schemas.microsoft.com/office/powerpoint/2010/main" val="1311531275"/>
+      </p:ext>
+    </p:extLst>
+  </p:cSld>
+  <p:clrMapOvr>
+    <a:masterClrMapping/>
+  </p:clrMapOvr>
+</p:sld>
+</file>
+
+<file path=ppt/slides/slide11.xml><?xml version="1.0" encoding="utf-8"?>
+<p:sld xmlns:a="http://schemas.openxmlformats.org/drawingml/2006/main" xmlns:r="http://schemas.openxmlformats.org/officeDocument/2006/relationships" xmlns:p="http://schemas.openxmlformats.org/presentationml/2006/main">
+  <p:cSld>
+    <p:spTree>
+      <p:nvGrpSpPr>
+        <p:cNvPr id="1" name=""/>
+        <p:cNvGrpSpPr/>
+        <p:nvPr/>
+      </p:nvGrpSpPr>
+      <p:grpSpPr>
+        <a:xfrm>
+          <a:off x="0" y="0"/>
+          <a:ext cx="0" cy="0"/>
+          <a:chOff x="0" y="0"/>
+          <a:chExt cx="0" cy="0"/>
+        </a:xfrm>
+      </p:grpSpPr>
       <p:sp>
         <p:nvSpPr>
           <p:cNvPr id="2" name="Rectangle 1"/>
@@ -3274,6 +3473,7 @@
           <a:lstStyle/>
           <a:p>
             <a:pPr algn="ctr"/>
+            <a:endParaRPr/>
           </a:p>
         </p:txBody>
       </p:sp>
@@ -3354,6 +3554,7 @@
           <a:lstStyle/>
           <a:p>
             <a:pPr algn="ctr"/>
+            <a:endParaRPr/>
           </a:p>
         </p:txBody>
       </p:sp>
@@ -3449,8 +3650,8 @@
 </p:sld>
 </file>
 
-<file path=ppt/slides/slide11.xml><?xml version="1.0" encoding="utf-8"?>
-<p:sld xmlns:a="http://schemas.openxmlformats.org/drawingml/2006/main" xmlns:p="http://schemas.openxmlformats.org/presentationml/2006/main" xmlns:r="http://schemas.openxmlformats.org/officeDocument/2006/relationships">
+<file path=ppt/slides/slide12.xml><?xml version="1.0" encoding="utf-8"?>
+<p:sld xmlns:a="http://schemas.openxmlformats.org/drawingml/2006/main" xmlns:r="http://schemas.openxmlformats.org/officeDocument/2006/relationships" xmlns:p="http://schemas.openxmlformats.org/presentationml/2006/main">
   <p:cSld>
     <p:spTree>
       <p:nvGrpSpPr>
@@ -3458,7 +3659,14 @@
         <p:cNvGrpSpPr/>
         <p:nvPr/>
       </p:nvGrpSpPr>
-      <p:grpSpPr/>
+      <p:grpSpPr>
+        <a:xfrm>
+          <a:off x="0" y="0"/>
+          <a:ext cx="0" cy="0"/>
+          <a:chOff x="0" y="0"/>
+          <a:chExt cx="0" cy="0"/>
+        </a:xfrm>
+      </p:grpSpPr>
       <p:sp>
         <p:nvSpPr>
           <p:cNvPr id="2" name="Rectangle 1"/>
@@ -3499,6 +3707,7 @@
           <a:lstStyle/>
           <a:p>
             <a:pPr algn="ctr"/>
+            <a:endParaRPr/>
           </a:p>
         </p:txBody>
       </p:sp>
@@ -3673,8 +3882,8 @@
 </p:sld>
 </file>
 
-<file path=ppt/slides/slide12.xml><?xml version="1.0" encoding="utf-8"?>
-<p:sld xmlns:a="http://schemas.openxmlformats.org/drawingml/2006/main" xmlns:p="http://schemas.openxmlformats.org/presentationml/2006/main" xmlns:r="http://schemas.openxmlformats.org/officeDocument/2006/relationships">
+<file path=ppt/slides/slide13.xml><?xml version="1.0" encoding="utf-8"?>
+<p:sld xmlns:a="http://schemas.openxmlformats.org/drawingml/2006/main" xmlns:r="http://schemas.openxmlformats.org/officeDocument/2006/relationships" xmlns:p="http://schemas.openxmlformats.org/presentationml/2006/main">
   <p:cSld>
     <p:spTree>
       <p:nvGrpSpPr>
@@ -3682,7 +3891,14 @@
         <p:cNvGrpSpPr/>
         <p:nvPr/>
       </p:nvGrpSpPr>
-      <p:grpSpPr/>
+      <p:grpSpPr>
+        <a:xfrm>
+          <a:off x="0" y="0"/>
+          <a:ext cx="0" cy="0"/>
+          <a:chOff x="0" y="0"/>
+          <a:chExt cx="0" cy="0"/>
+        </a:xfrm>
+      </p:grpSpPr>
       <p:sp>
         <p:nvSpPr>
           <p:cNvPr id="2" name="Rectangle 1"/>
@@ -3723,6 +3939,7 @@
           <a:lstStyle/>
           <a:p>
             <a:pPr algn="ctr"/>
+            <a:endParaRPr/>
           </a:p>
         </p:txBody>
       </p:sp>
@@ -3898,7 +4115,7 @@
 </file>
 
 <file path=ppt/slides/slide2.xml><?xml version="1.0" encoding="utf-8"?>
-<p:sld xmlns:a="http://schemas.openxmlformats.org/drawingml/2006/main" xmlns:p="http://schemas.openxmlformats.org/presentationml/2006/main" xmlns:r="http://schemas.openxmlformats.org/officeDocument/2006/relationships">
+<p:sld xmlns:a="http://schemas.openxmlformats.org/drawingml/2006/main" xmlns:r="http://schemas.openxmlformats.org/officeDocument/2006/relationships" xmlns:p="http://schemas.openxmlformats.org/presentationml/2006/main">
   <p:cSld>
     <p:spTree>
       <p:nvGrpSpPr>
@@ -3906,7 +4123,14 @@
         <p:cNvGrpSpPr/>
         <p:nvPr/>
       </p:nvGrpSpPr>
-      <p:grpSpPr/>
+      <p:grpSpPr>
+        <a:xfrm>
+          <a:off x="0" y="0"/>
+          <a:ext cx="0" cy="0"/>
+          <a:chOff x="0" y="0"/>
+          <a:chExt cx="0" cy="0"/>
+        </a:xfrm>
+      </p:grpSpPr>
       <p:sp>
         <p:nvSpPr>
           <p:cNvPr id="2" name="Rectangle 1"/>
@@ -3947,6 +4171,7 @@
           <a:lstStyle/>
           <a:p>
             <a:pPr algn="ctr"/>
+            <a:endParaRPr/>
           </a:p>
         </p:txBody>
       </p:sp>
@@ -3994,7 +4219,7 @@
         <p:spPr>
           <a:xfrm>
             <a:off x="457200" y="1371600"/>
-            <a:ext cx="8229600" cy="5029200"/>
+            <a:ext cx="8229600" cy="3631763"/>
           </a:xfrm>
           <a:prstGeom prst="rect">
             <a:avLst/>
@@ -4018,7 +4243,16 @@
               </a:defRPr>
             </a:pPr>
             <a:r>
-              <a:t>• cDPM Recovery Simulation Tool for SOCAMM2</a:t>
+              <a:rPr dirty="0"/>
+              <a:t>• </a:t>
+            </a:r>
+            <a:r>
+              <a:rPr dirty="0" err="1"/>
+              <a:t>cDPM</a:t>
+            </a:r>
+            <a:r>
+              <a:rPr dirty="0"/>
+              <a:t> Recovery Simulation Tool for SOCAMM2</a:t>
             </a:r>
           </a:p>
           <a:p>
@@ -4033,7 +4267,8 @@
               </a:defRPr>
             </a:pPr>
             <a:r>
-              <a:t>• Uses Kevin Roos's Hybrid DPM approach</a:t>
+              <a:rPr dirty="0"/>
+              <a:t>• Uses Hybrid DPM approach</a:t>
             </a:r>
           </a:p>
           <a:p>
@@ -4048,6 +4283,7 @@
               </a:defRPr>
             </a:pPr>
             <a:r>
+              <a:rPr dirty="0"/>
               <a:t>• Analyzes three recovery types:</a:t>
             </a:r>
           </a:p>
@@ -4063,7 +4299,24 @@
               </a:defRPr>
             </a:pPr>
             <a:r>
-              <a:t>•    - New RPx Fix (VERIFIED) - False miscompare detection</a:t>
+              <a:rPr dirty="0"/>
+              <a:t>•    - New </a:t>
+            </a:r>
+            <a:r>
+              <a:rPr dirty="0" err="1"/>
+              <a:t>RPx</a:t>
+            </a:r>
+            <a:r>
+              <a:rPr dirty="0"/>
+              <a:t> Fix (VERIFIED) - False </a:t>
+            </a:r>
+            <a:r>
+              <a:rPr dirty="0" err="1"/>
+              <a:t>miscompare</a:t>
+            </a:r>
+            <a:r>
+              <a:rPr dirty="0"/>
+              <a:t> detection</a:t>
             </a:r>
           </a:p>
           <a:p>
@@ -4078,6 +4331,7 @@
               </a:defRPr>
             </a:pPr>
             <a:r>
+              <a:rPr dirty="0"/>
               <a:t>•    - New BIOS Fix (PROJECTED) - MULTI_BANK_MULTI_DQ timing</a:t>
             </a:r>
           </a:p>
@@ -4093,6 +4347,7 @@
               </a:defRPr>
             </a:pPr>
             <a:r>
+              <a:rPr dirty="0"/>
               <a:t>•    - HW + SOP Fix (PROJECTED) - Hang recovery</a:t>
             </a:r>
           </a:p>
@@ -4108,6 +4363,7 @@
               </a:defRPr>
             </a:pPr>
             <a:r>
+              <a:rPr dirty="0"/>
               <a:t>• Generates interactive HTML reports with heatmaps</a:t>
             </a:r>
           </a:p>
@@ -4123,6 +4379,7 @@
               </a:defRPr>
             </a:pPr>
             <a:r>
+              <a:rPr dirty="0"/>
               <a:t>• Shows single week + 4-week cumulative analysis</a:t>
             </a:r>
           </a:p>
@@ -4137,7 +4394,7 @@
 </file>
 
 <file path=ppt/slides/slide3.xml><?xml version="1.0" encoding="utf-8"?>
-<p:sld xmlns:a="http://schemas.openxmlformats.org/drawingml/2006/main" xmlns:p="http://schemas.openxmlformats.org/presentationml/2006/main" xmlns:r="http://schemas.openxmlformats.org/officeDocument/2006/relationships">
+<p:sld xmlns:a="http://schemas.openxmlformats.org/drawingml/2006/main" xmlns:r="http://schemas.openxmlformats.org/officeDocument/2006/relationships" xmlns:p="http://schemas.openxmlformats.org/presentationml/2006/main">
   <p:cSld>
     <p:spTree>
       <p:nvGrpSpPr>
@@ -4145,7 +4402,14 @@
         <p:cNvGrpSpPr/>
         <p:nvPr/>
       </p:nvGrpSpPr>
-      <p:grpSpPr/>
+      <p:grpSpPr>
+        <a:xfrm>
+          <a:off x="0" y="0"/>
+          <a:ext cx="0" cy="0"/>
+          <a:chOff x="0" y="0"/>
+          <a:chExt cx="0" cy="0"/>
+        </a:xfrm>
+      </p:grpSpPr>
       <p:sp>
         <p:nvSpPr>
           <p:cNvPr id="2" name="Rectangle 1"/>
@@ -4186,6 +4450,7 @@
           <a:lstStyle/>
           <a:p>
             <a:pPr algn="ctr"/>
+            <a:endParaRPr/>
           </a:p>
         </p:txBody>
       </p:sp>
@@ -4376,7 +4641,7 @@
 </file>
 
 <file path=ppt/slides/slide4.xml><?xml version="1.0" encoding="utf-8"?>
-<p:sld xmlns:a="http://schemas.openxmlformats.org/drawingml/2006/main" xmlns:p="http://schemas.openxmlformats.org/presentationml/2006/main" xmlns:r="http://schemas.openxmlformats.org/officeDocument/2006/relationships">
+<p:sld xmlns:a="http://schemas.openxmlformats.org/drawingml/2006/main" xmlns:r="http://schemas.openxmlformats.org/officeDocument/2006/relationships" xmlns:p="http://schemas.openxmlformats.org/presentationml/2006/main">
   <p:cSld>
     <p:spTree>
       <p:nvGrpSpPr>
@@ -4384,7 +4649,14 @@
         <p:cNvGrpSpPr/>
         <p:nvPr/>
       </p:nvGrpSpPr>
-      <p:grpSpPr/>
+      <p:grpSpPr>
+        <a:xfrm>
+          <a:off x="0" y="0"/>
+          <a:ext cx="0" cy="0"/>
+          <a:chOff x="0" y="0"/>
+          <a:chExt cx="0" cy="0"/>
+        </a:xfrm>
+      </p:grpSpPr>
       <p:sp>
         <p:nvSpPr>
           <p:cNvPr id="2" name="Rectangle 1"/>
@@ -4425,6 +4697,7 @@
           <a:lstStyle/>
           <a:p>
             <a:pPr algn="ctr"/>
+            <a:endParaRPr/>
           </a:p>
         </p:txBody>
       </p:sp>
@@ -4472,7 +4745,7 @@
         <p:spPr>
           <a:xfrm>
             <a:off x="457200" y="1371600"/>
-            <a:ext cx="8229600" cy="5029200"/>
+            <a:ext cx="8229600" cy="5016758"/>
           </a:xfrm>
           <a:prstGeom prst="rect">
             <a:avLst/>
@@ -4496,6 +4769,7 @@
               </a:defRPr>
             </a:pPr>
             <a:r>
+              <a:rPr dirty="0"/>
               <a:t>• Step 1: Install MU App Store CLI</a:t>
             </a:r>
           </a:p>
@@ -4511,7 +4785,16 @@
               </a:defRPr>
             </a:pPr>
             <a:r>
-              <a:t>• Step 2: Create pyproject.toml with metadata</a:t>
+              <a:rPr dirty="0"/>
+              <a:t>• Step 2: Create </a:t>
+            </a:r>
+            <a:r>
+              <a:rPr dirty="0" err="1"/>
+              <a:t>pyproject.toml</a:t>
+            </a:r>
+            <a:r>
+              <a:rPr dirty="0"/>
+              <a:t> with metadata</a:t>
             </a:r>
           </a:p>
           <a:p>
@@ -4526,6 +4809,7 @@
               </a:defRPr>
             </a:pPr>
             <a:r>
+              <a:rPr dirty="0"/>
               <a:t>• Step 3: Structure code as proper Python package</a:t>
             </a:r>
           </a:p>
@@ -4541,7 +4825,16 @@
               </a:defRPr>
             </a:pPr>
             <a:r>
-              <a:t>• Step 4: Run appstore publish command</a:t>
+              <a:rPr dirty="0"/>
+              <a:t>• Step 4: Run </a:t>
+            </a:r>
+            <a:r>
+              <a:rPr dirty="0" err="1"/>
+              <a:t>appstore</a:t>
+            </a:r>
+            <a:r>
+              <a:rPr dirty="0"/>
+              <a:t> publish command</a:t>
             </a:r>
           </a:p>
           <a:p>
@@ -4556,6 +4849,7 @@
               </a:defRPr>
             </a:pPr>
             <a:r>
+              <a:rPr dirty="0"/>
               <a:t>• Step 5: Test installation from app store</a:t>
             </a:r>
           </a:p>
@@ -4571,6 +4865,7 @@
               </a:defRPr>
             </a:pPr>
             <a:r>
+              <a:rPr dirty="0"/>
               <a:t>• Step 6: Iterate and fix issues</a:t>
             </a:r>
           </a:p>
@@ -4586,8 +4881,77 @@
               </a:defRPr>
             </a:pPr>
             <a:r>
+              <a:rPr dirty="0"/>
               <a:t>• Final: Successfully published v1.0.3!</a:t>
             </a:r>
+            <a:endParaRPr lang="en-US" dirty="0"/>
+          </a:p>
+          <a:p>
+            <a:pPr>
+              <a:spcAft>
+                <a:spcPts val="1200"/>
+              </a:spcAft>
+              <a:defRPr sz="2000">
+                <a:solidFill>
+                  <a:srgbClr val="323232"/>
+                </a:solidFill>
+              </a:defRPr>
+            </a:pPr>
+            <a:endParaRPr lang="en-US" dirty="0"/>
+          </a:p>
+          <a:p>
+            <a:pPr>
+              <a:spcAft>
+                <a:spcPts val="1200"/>
+              </a:spcAft>
+              <a:defRPr sz="2000">
+                <a:solidFill>
+                  <a:srgbClr val="323232"/>
+                </a:solidFill>
+              </a:defRPr>
+            </a:pPr>
+            <a:r>
+              <a:rPr lang="en-US" dirty="0"/>
+              <a:t>Links:</a:t>
+            </a:r>
+          </a:p>
+          <a:p>
+            <a:pPr>
+              <a:spcAft>
+                <a:spcPts val="1200"/>
+              </a:spcAft>
+              <a:defRPr sz="2000">
+                <a:solidFill>
+                  <a:srgbClr val="323232"/>
+                </a:solidFill>
+              </a:defRPr>
+            </a:pPr>
+            <a:r>
+              <a:rPr lang="en-US" sz="2000" dirty="0">
+                <a:hlinkClick r:id="rId2"/>
+              </a:rPr>
+              <a:t>Mu App Store - DEG PE – Confluence</a:t>
+            </a:r>
+            <a:endParaRPr lang="en-US" sz="2000" dirty="0"/>
+          </a:p>
+          <a:p>
+            <a:pPr>
+              <a:spcAft>
+                <a:spcPts val="1200"/>
+              </a:spcAft>
+              <a:defRPr sz="2000">
+                <a:solidFill>
+                  <a:srgbClr val="323232"/>
+                </a:solidFill>
+              </a:defRPr>
+            </a:pPr>
+            <a:r>
+              <a:rPr lang="en-US" sz="2000" dirty="0">
+                <a:hlinkClick r:id="rId3"/>
+              </a:rPr>
+              <a:t>Mu App Store</a:t>
+            </a:r>
+            <a:endParaRPr dirty="0"/>
           </a:p>
         </p:txBody>
       </p:sp>
@@ -4600,7 +4964,7 @@
 </file>
 
 <file path=ppt/slides/slide5.xml><?xml version="1.0" encoding="utf-8"?>
-<p:sld xmlns:a="http://schemas.openxmlformats.org/drawingml/2006/main" xmlns:p="http://schemas.openxmlformats.org/presentationml/2006/main" xmlns:r="http://schemas.openxmlformats.org/officeDocument/2006/relationships">
+<p:sld xmlns:a="http://schemas.openxmlformats.org/drawingml/2006/main" xmlns:r="http://schemas.openxmlformats.org/officeDocument/2006/relationships" xmlns:p="http://schemas.openxmlformats.org/presentationml/2006/main">
   <p:cSld>
     <p:spTree>
       <p:nvGrpSpPr>
@@ -4608,7 +4972,14 @@
         <p:cNvGrpSpPr/>
         <p:nvPr/>
       </p:nvGrpSpPr>
-      <p:grpSpPr/>
+      <p:grpSpPr>
+        <a:xfrm>
+          <a:off x="0" y="0"/>
+          <a:ext cx="0" cy="0"/>
+          <a:chOff x="0" y="0"/>
+          <a:chExt cx="0" cy="0"/>
+        </a:xfrm>
+      </p:grpSpPr>
       <p:sp>
         <p:nvSpPr>
           <p:cNvPr id="2" name="Rectangle 1"/>
@@ -4649,6 +5020,7 @@
           <a:lstStyle/>
           <a:p>
             <a:pPr algn="ctr"/>
+            <a:endParaRPr/>
           </a:p>
         </p:txBody>
       </p:sp>
@@ -4764,6 +5136,7 @@
           <a:lstStyle/>
           <a:p>
             <a:pPr algn="ctr"/>
+            <a:endParaRPr/>
           </a:p>
         </p:txBody>
       </p:sp>
@@ -4884,6 +5257,7 @@
           <a:lstStyle/>
           <a:p>
             <a:pPr algn="ctr"/>
+            <a:endParaRPr/>
           </a:p>
         </p:txBody>
       </p:sp>
@@ -4949,7 +5323,7 @@
 </file>
 
 <file path=ppt/slides/slide6.xml><?xml version="1.0" encoding="utf-8"?>
-<p:sld xmlns:a="http://schemas.openxmlformats.org/drawingml/2006/main" xmlns:p="http://schemas.openxmlformats.org/presentationml/2006/main" xmlns:r="http://schemas.openxmlformats.org/officeDocument/2006/relationships">
+<p:sld xmlns:a="http://schemas.openxmlformats.org/drawingml/2006/main" xmlns:r="http://schemas.openxmlformats.org/officeDocument/2006/relationships" xmlns:p="http://schemas.openxmlformats.org/presentationml/2006/main">
   <p:cSld>
     <p:spTree>
       <p:nvGrpSpPr>
@@ -4957,7 +5331,14 @@
         <p:cNvGrpSpPr/>
         <p:nvPr/>
       </p:nvGrpSpPr>
-      <p:grpSpPr/>
+      <p:grpSpPr>
+        <a:xfrm>
+          <a:off x="0" y="0"/>
+          <a:ext cx="0" cy="0"/>
+          <a:chOff x="0" y="0"/>
+          <a:chExt cx="0" cy="0"/>
+        </a:xfrm>
+      </p:grpSpPr>
       <p:sp>
         <p:nvSpPr>
           <p:cNvPr id="2" name="Rectangle 1"/>
@@ -4998,6 +5379,7 @@
           <a:lstStyle/>
           <a:p>
             <a:pPr algn="ctr"/>
+            <a:endParaRPr/>
           </a:p>
         </p:txBody>
       </p:sp>
@@ -5113,6 +5495,7 @@
           <a:lstStyle/>
           <a:p>
             <a:pPr algn="ctr"/>
+            <a:endParaRPr/>
           </a:p>
         </p:txBody>
       </p:sp>
@@ -5233,6 +5616,7 @@
           <a:lstStyle/>
           <a:p>
             <a:pPr algn="ctr"/>
+            <a:endParaRPr/>
           </a:p>
         </p:txBody>
       </p:sp>
@@ -5298,7 +5682,7 @@
 </file>
 
 <file path=ppt/slides/slide7.xml><?xml version="1.0" encoding="utf-8"?>
-<p:sld xmlns:a="http://schemas.openxmlformats.org/drawingml/2006/main" xmlns:p="http://schemas.openxmlformats.org/presentationml/2006/main" xmlns:r="http://schemas.openxmlformats.org/officeDocument/2006/relationships">
+<p:sld xmlns:a="http://schemas.openxmlformats.org/drawingml/2006/main" xmlns:r="http://schemas.openxmlformats.org/officeDocument/2006/relationships" xmlns:p="http://schemas.openxmlformats.org/presentationml/2006/main">
   <p:cSld>
     <p:spTree>
       <p:nvGrpSpPr>
@@ -5306,7 +5690,14 @@
         <p:cNvGrpSpPr/>
         <p:nvPr/>
       </p:nvGrpSpPr>
-      <p:grpSpPr/>
+      <p:grpSpPr>
+        <a:xfrm>
+          <a:off x="0" y="0"/>
+          <a:ext cx="0" cy="0"/>
+          <a:chOff x="0" y="0"/>
+          <a:chExt cx="0" cy="0"/>
+        </a:xfrm>
+      </p:grpSpPr>
       <p:sp>
         <p:nvSpPr>
           <p:cNvPr id="2" name="Rectangle 1"/>
@@ -5347,6 +5738,7 @@
           <a:lstStyle/>
           <a:p>
             <a:pPr algn="ctr"/>
+            <a:endParaRPr/>
           </a:p>
         </p:txBody>
       </p:sp>
@@ -5462,6 +5854,7 @@
           <a:lstStyle/>
           <a:p>
             <a:pPr algn="ctr"/>
+            <a:endParaRPr/>
           </a:p>
         </p:txBody>
       </p:sp>
@@ -5582,6 +5975,7 @@
           <a:lstStyle/>
           <a:p>
             <a:pPr algn="ctr"/>
+            <a:endParaRPr/>
           </a:p>
         </p:txBody>
       </p:sp>
@@ -5659,7 +6053,7 @@
 </file>
 
 <file path=ppt/slides/slide8.xml><?xml version="1.0" encoding="utf-8"?>
-<p:sld xmlns:a="http://schemas.openxmlformats.org/drawingml/2006/main" xmlns:p="http://schemas.openxmlformats.org/presentationml/2006/main" xmlns:r="http://schemas.openxmlformats.org/officeDocument/2006/relationships">
+<p:sld xmlns:a="http://schemas.openxmlformats.org/drawingml/2006/main" xmlns:r="http://schemas.openxmlformats.org/officeDocument/2006/relationships" xmlns:p="http://schemas.openxmlformats.org/presentationml/2006/main">
   <p:cSld>
     <p:spTree>
       <p:nvGrpSpPr>
@@ -5667,7 +6061,14 @@
         <p:cNvGrpSpPr/>
         <p:nvPr/>
       </p:nvGrpSpPr>
-      <p:grpSpPr/>
+      <p:grpSpPr>
+        <a:xfrm>
+          <a:off x="0" y="0"/>
+          <a:ext cx="0" cy="0"/>
+          <a:chOff x="0" y="0"/>
+          <a:chExt cx="0" cy="0"/>
+        </a:xfrm>
+      </p:grpSpPr>
       <p:sp>
         <p:nvSpPr>
           <p:cNvPr id="2" name="Rectangle 1"/>
@@ -5708,6 +6109,7 @@
           <a:lstStyle/>
           <a:p>
             <a:pPr algn="ctr"/>
+            <a:endParaRPr/>
           </a:p>
         </p:txBody>
       </p:sp>
@@ -5823,6 +6225,7 @@
           <a:lstStyle/>
           <a:p>
             <a:pPr algn="ctr"/>
+            <a:endParaRPr/>
           </a:p>
         </p:txBody>
       </p:sp>
@@ -5943,6 +6346,7 @@
           <a:lstStyle/>
           <a:p>
             <a:pPr algn="ctr"/>
+            <a:endParaRPr/>
           </a:p>
         </p:txBody>
       </p:sp>
@@ -6013,7 +6417,7 @@
 </file>
 
 <file path=ppt/slides/slide9.xml><?xml version="1.0" encoding="utf-8"?>
-<p:sld xmlns:a="http://schemas.openxmlformats.org/drawingml/2006/main" xmlns:p="http://schemas.openxmlformats.org/presentationml/2006/main" xmlns:r="http://schemas.openxmlformats.org/officeDocument/2006/relationships">
+<p:sld xmlns:a="http://schemas.openxmlformats.org/drawingml/2006/main" xmlns:r="http://schemas.openxmlformats.org/officeDocument/2006/relationships" xmlns:p="http://schemas.openxmlformats.org/presentationml/2006/main">
   <p:cSld>
     <p:spTree>
       <p:nvGrpSpPr>
@@ -6021,7 +6425,14 @@
         <p:cNvGrpSpPr/>
         <p:nvPr/>
       </p:nvGrpSpPr>
-      <p:grpSpPr/>
+      <p:grpSpPr>
+        <a:xfrm>
+          <a:off x="0" y="0"/>
+          <a:ext cx="0" cy="0"/>
+          <a:chOff x="0" y="0"/>
+          <a:chExt cx="0" cy="0"/>
+        </a:xfrm>
+      </p:grpSpPr>
       <p:sp>
         <p:nvSpPr>
           <p:cNvPr id="2" name="Rectangle 1"/>
@@ -6062,6 +6473,7 @@
           <a:lstStyle/>
           <a:p>
             <a:pPr algn="ctr"/>
+            <a:endParaRPr/>
           </a:p>
         </p:txBody>
       </p:sp>
@@ -6142,6 +6554,7 @@
           <a:lstStyle/>
           <a:p>
             <a:pPr algn="ctr"/>
+            <a:endParaRPr/>
           </a:p>
         </p:txBody>
       </p:sp>
@@ -6551,4 +6964,10 @@
   </a:objectDefaults>
   <a:extraClrSchemeLst/>
 </a:theme>
+</file>
+
+<file path=docMetadata/LabelInfo.xml><?xml version="1.0" encoding="utf-8"?>
+<clbl:labelList xmlns:clbl="http://schemas.microsoft.com/office/2020/mipLabelMetadata">
+  <clbl:label id="{37874100-6000-43b6-a204-2d77792600b9}" enabled="1" method="Standard" siteId="{f38a5ecd-2813-4862-b11b-ac1d563c806f}" contentBits="3" removed="0"/>
+</clbl:labelList>
 </file>
</xml_diff>